<commit_message>
test: strengthen exam adversarial data
</commit_message>
<xml_diff>
--- a/courseware/202612_DSA_W17_Final_Machine_Exam.pptx
+++ b/courseware/202612_DSA_W17_Final_Machine_Exam.pptx
@@ -5177,7 +5177,7 @@
                 <a:latin typeface="Segoe UI"/>
                 <a:ea typeface="微软雅黑"/>
               </a:rPr>
-              <a:t>：n = 2×10⁵ 随机 1000 个姓名 —— 卡掉 </a:t>
+              <a:t>：n = 2×10⁵、姓名两两不同 —— 稳定卡掉 </a:t>
             </a:r>
             <a:r>
               <a:rPr sz="1879" b="0" i="0">
@@ -8224,7 +8224,7 @@
                 <a:latin typeface="Segoe UI"/>
                 <a:ea typeface="微软雅黑"/>
               </a:rPr>
-              <a:t>卡时数据</a:t>
+              <a:t>右链</a:t>
             </a:r>
             <a:r>
               <a:rPr sz="2000" b="0" i="0">
@@ -8234,27 +8234,7 @@
                 <a:latin typeface="Segoe UI"/>
                 <a:ea typeface="微软雅黑"/>
               </a:rPr>
-              <a:t>：</a:t>
-            </a:r>
-            <a:r>
-              <a:rPr sz="2000" b="1" i="0">
-                <a:solidFill>
-                  <a:srgbClr val="12395B"/>
-                </a:solidFill>
-                <a:latin typeface="Segoe UI"/>
-                <a:ea typeface="微软雅黑"/>
-              </a:rPr>
-              <a:t>链状树</a:t>
-            </a:r>
-            <a:r>
-              <a:rPr sz="2000" b="0" i="0">
-                <a:solidFill>
-                  <a:srgbClr val="242A33"/>
-                </a:solidFill>
-                <a:latin typeface="Segoe UI"/>
-                <a:ea typeface="微软雅黑"/>
-              </a:rPr>
-              <a:t>（前序 = 中序 = 1..n）—— 测递归深度</a:t>
+              <a:t>：前序 = 中序 = 1..n，测递归深度</a:t>
             </a:r>
           </a:p>
           <a:p>
@@ -8277,7 +8257,27 @@
                 <a:latin typeface="Segoe UI"/>
                 <a:ea typeface="微软雅黑"/>
               </a:rPr>
-              <a:t>•  ⚠️ 卡掉每层用 </a:t>
+              <a:t>•  ⚠️ </a:t>
+            </a:r>
+            <a:r>
+              <a:rPr sz="2000" b="1" i="0">
+                <a:solidFill>
+                  <a:srgbClr val="12395B"/>
+                </a:solidFill>
+                <a:latin typeface="Segoe UI"/>
+                <a:ea typeface="微软雅黑"/>
+              </a:rPr>
+              <a:t>左链</a:t>
+            </a:r>
+            <a:r>
+              <a:rPr sz="2000" b="0" i="0">
+                <a:solidFill>
+                  <a:srgbClr val="242A33"/>
+                </a:solidFill>
+                <a:latin typeface="Segoe UI"/>
+                <a:ea typeface="微软雅黑"/>
+              </a:rPr>
+              <a:t>：前序 = n..1、中序 = 1..n，稳定卡掉有界 </a:t>
             </a:r>
             <a:r>
               <a:rPr sz="1879" b="0" i="0">
@@ -8297,7 +8297,7 @@
                 <a:latin typeface="Segoe UI"/>
                 <a:ea typeface="微软雅黑"/>
               </a:rPr>
-              <a:t> 的 O(n²) 写法与切片建树的 O(n²) 空间</a:t>
+              <a:t> 的 O(n²) 与切片建树</a:t>
             </a:r>
           </a:p>
           <a:p>
@@ -10998,6 +10998,49 @@
                 <a:ea typeface="微软雅黑"/>
               </a:rPr>
               <a:t>：k=0（普通 MST）、k=m（答案 0）、不连通、重边自环、w=0</a:t>
+            </a:r>
+          </a:p>
+          <a:p>
+            <a:pPr algn="l">
+              <a:lnSpc>
+                <a:spcPct val="132000"/>
+              </a:lnSpc>
+              <a:spcBef>
+                <a:spcPts val="0"/>
+              </a:spcBef>
+              <a:spcAft>
+                <a:spcPts val="1240"/>
+              </a:spcAft>
+            </a:pPr>
+            <a:r>
+              <a:rPr sz="2000" b="0" i="0">
+                <a:solidFill>
+                  <a:srgbClr val="242A33"/>
+                </a:solidFill>
+                <a:latin typeface="Segoe UI"/>
+                <a:ea typeface="微软雅黑"/>
+              </a:rPr>
+              <a:t>•  </a:t>
+            </a:r>
+            <a:r>
+              <a:rPr sz="2000" b="1" i="0">
+                <a:solidFill>
+                  <a:srgbClr val="12395B"/>
+                </a:solidFill>
+                <a:latin typeface="Segoe UI"/>
+                <a:ea typeface="微软雅黑"/>
+              </a:rPr>
+              <a:t>并查集卡时</a:t>
+            </a:r>
+            <a:r>
+              <a:rPr sz="2000" b="0" i="0">
+                <a:solidFill>
+                  <a:srgbClr val="242A33"/>
+                </a:solidFill>
+                <a:latin typeface="Segoe UI"/>
+                <a:ea typeface="微软雅黑"/>
+              </a:rPr>
+              <a:t>：权 0 的 (1,2)…(n-1,n) 建父链，再重复权 1 的 (1,n)，测无路径压缩</a:t>
             </a:r>
           </a:p>
           <a:p>

</xml_diff>